<commit_message>
Added notes on the meeting of this morning, and did minor adjustments to the powerpoint prior to the meeting
</commit_message>
<xml_diff>
--- a/dev_documents/meetings/meeting_09/meeting_09.pptx
+++ b/dev_documents/meetings/meeting_09/meeting_09.pptx
@@ -119,6 +119,11 @@
       </a:defRPr>
     </a:lvl9pPr>
   </p:defaultTextStyle>
+  <p:extLst>
+    <p:ext uri="{EFAFB233-063F-42B5-8137-9DF3F51BA10A}">
+      <p15:sldGuideLst xmlns:p15="http://schemas.microsoft.com/office/powerpoint/2012/main"/>
+    </p:ext>
+  </p:extLst>
 </p:presentation>
 </file>
 
@@ -271,7 +276,7 @@
           <a:p>
             <a:fld id="{3D2E99B4-F11D-4563-BA65-B73021F0CC66}" type="datetimeFigureOut">
               <a:rPr lang="de-CH" smtClean="0"/>
-              <a:t>22.01.2026</a:t>
+              <a:t>23.01.2026</a:t>
             </a:fld>
             <a:endParaRPr lang="de-CH"/>
           </a:p>
@@ -471,7 +476,7 @@
           <a:p>
             <a:fld id="{3D2E99B4-F11D-4563-BA65-B73021F0CC66}" type="datetimeFigureOut">
               <a:rPr lang="de-CH" smtClean="0"/>
-              <a:t>22.01.2026</a:t>
+              <a:t>23.01.2026</a:t>
             </a:fld>
             <a:endParaRPr lang="de-CH"/>
           </a:p>
@@ -681,7 +686,7 @@
           <a:p>
             <a:fld id="{3D2E99B4-F11D-4563-BA65-B73021F0CC66}" type="datetimeFigureOut">
               <a:rPr lang="de-CH" smtClean="0"/>
-              <a:t>22.01.2026</a:t>
+              <a:t>23.01.2026</a:t>
             </a:fld>
             <a:endParaRPr lang="de-CH"/>
           </a:p>
@@ -881,7 +886,7 @@
           <a:p>
             <a:fld id="{3D2E99B4-F11D-4563-BA65-B73021F0CC66}" type="datetimeFigureOut">
               <a:rPr lang="de-CH" smtClean="0"/>
-              <a:t>22.01.2026</a:t>
+              <a:t>23.01.2026</a:t>
             </a:fld>
             <a:endParaRPr lang="de-CH"/>
           </a:p>
@@ -1157,7 +1162,7 @@
           <a:p>
             <a:fld id="{3D2E99B4-F11D-4563-BA65-B73021F0CC66}" type="datetimeFigureOut">
               <a:rPr lang="de-CH" smtClean="0"/>
-              <a:t>22.01.2026</a:t>
+              <a:t>23.01.2026</a:t>
             </a:fld>
             <a:endParaRPr lang="de-CH"/>
           </a:p>
@@ -1425,7 +1430,7 @@
           <a:p>
             <a:fld id="{3D2E99B4-F11D-4563-BA65-B73021F0CC66}" type="datetimeFigureOut">
               <a:rPr lang="de-CH" smtClean="0"/>
-              <a:t>22.01.2026</a:t>
+              <a:t>23.01.2026</a:t>
             </a:fld>
             <a:endParaRPr lang="de-CH"/>
           </a:p>
@@ -1840,7 +1845,7 @@
           <a:p>
             <a:fld id="{3D2E99B4-F11D-4563-BA65-B73021F0CC66}" type="datetimeFigureOut">
               <a:rPr lang="de-CH" smtClean="0"/>
-              <a:t>22.01.2026</a:t>
+              <a:t>23.01.2026</a:t>
             </a:fld>
             <a:endParaRPr lang="de-CH"/>
           </a:p>
@@ -1982,7 +1987,7 @@
           <a:p>
             <a:fld id="{3D2E99B4-F11D-4563-BA65-B73021F0CC66}" type="datetimeFigureOut">
               <a:rPr lang="de-CH" smtClean="0"/>
-              <a:t>22.01.2026</a:t>
+              <a:t>23.01.2026</a:t>
             </a:fld>
             <a:endParaRPr lang="de-CH"/>
           </a:p>
@@ -2095,7 +2100,7 @@
           <a:p>
             <a:fld id="{3D2E99B4-F11D-4563-BA65-B73021F0CC66}" type="datetimeFigureOut">
               <a:rPr lang="de-CH" smtClean="0"/>
-              <a:t>22.01.2026</a:t>
+              <a:t>23.01.2026</a:t>
             </a:fld>
             <a:endParaRPr lang="de-CH"/>
           </a:p>
@@ -2408,7 +2413,7 @@
           <a:p>
             <a:fld id="{3D2E99B4-F11D-4563-BA65-B73021F0CC66}" type="datetimeFigureOut">
               <a:rPr lang="de-CH" smtClean="0"/>
-              <a:t>22.01.2026</a:t>
+              <a:t>23.01.2026</a:t>
             </a:fld>
             <a:endParaRPr lang="de-CH"/>
           </a:p>
@@ -2697,7 +2702,7 @@
           <a:p>
             <a:fld id="{3D2E99B4-F11D-4563-BA65-B73021F0CC66}" type="datetimeFigureOut">
               <a:rPr lang="de-CH" smtClean="0"/>
-              <a:t>22.01.2026</a:t>
+              <a:t>23.01.2026</a:t>
             </a:fld>
             <a:endParaRPr lang="de-CH"/>
           </a:p>
@@ -2940,7 +2945,7 @@
           <a:p>
             <a:fld id="{3D2E99B4-F11D-4563-BA65-B73021F0CC66}" type="datetimeFigureOut">
               <a:rPr lang="de-CH" smtClean="0"/>
-              <a:t>22.01.2026</a:t>
+              <a:t>23.01.2026</a:t>
             </a:fld>
             <a:endParaRPr lang="de-CH"/>
           </a:p>

</xml_diff>